<commit_message>
Correct author names in final report and presentation
</commit_message>
<xml_diff>
--- a/presentation/final_presentation.pptx
+++ b/presentation/final_presentation.pptx
@@ -653,7 +653,7 @@
           <a:lstStyle/>
           <a:p>
             <a:r>
-              <a:t>GrAndezit | 1:00 | Summarize the evidence without claiming a robust 25% optimum or a proven cause for every error.</a:t>
+              <a:t>Maksym | 1:00 | Summarize the evidence without claiming a robust 25% optimum or a proven cause for every error.</a:t>
             </a:r>
           </a:p>
         </p:txBody>
@@ -933,7 +933,7 @@
           <a:lstStyle/>
           <a:p>
             <a:r>
-              <a:t>GrAndezit | 1:10 | Explain prompt contrast and screened replacements. State that automatic filters are quality proxies, not factual guarantees.</a:t>
+              <a:t>Maksym | 1:10 | Explain prompt contrast and screened replacements. State that automatic filters are quality proxies, not factual guarantees.</a:t>
             </a:r>
           </a:p>
         </p:txBody>
@@ -1003,7 +1003,7 @@
           <a:lstStyle/>
           <a:p>
             <a:r>
-              <a:t>GrAndezit | 1:10 | Explain distinct-2 and semantic diversity briefly. Mention the small review sample and repeated headline artifacts.</a:t>
+              <a:t>Maksym | 1:10 | Explain distinct-2 and semantic diversity briefly. Mention the small review sample and repeated headline artifacts.</a:t>
             </a:r>
           </a:p>
         </p:txBody>
@@ -4443,7 +4443,7 @@
               </a:defRPr>
             </a:pPr>
             <a:r>
-              <a:t>• Oleksandr Buhrii &amp; GrAndezit</a:t>
+              <a:t>• Prepared by Oleksandr Buhrii &amp; Maksym Khramtsov</a:t>
             </a:r>
           </a:p>
         </p:txBody>
@@ -5502,7 +5502,7 @@
               </a:defRPr>
             </a:pPr>
             <a:r>
-              <a:t>• GrAndezit: prompts, Qwen generation, filtering, quality/diversity audits</a:t>
+              <a:t>• Maksym: prompts, Qwen generation, filtering, quality/diversity audits</a:t>
             </a:r>
           </a:p>
         </p:txBody>

</xml_diff>